<commit_message>
add kaggle dataset link in presentation
</commit_message>
<xml_diff>
--- a/Recipe_Recommender_Presentation.pptx
+++ b/Recipe_Recommender_Presentation.pptx
@@ -3354,7 +3354,7 @@
                 </a:solidFill>
                 <a:latin typeface="Arial"/>
               </a:rPr>
-              <a:t>Libraries and Frameworks: </a:t>
+              <a:t>Kaggle Dataset: </a:t>
             </a:r>
             <a:r>
               <a:rPr sz="1150">
@@ -3363,7 +3363,7 @@
                 </a:solidFill>
                 <a:latin typeface="Arial"/>
               </a:rPr>
-              <a:t>Python, Scikit Surprise, Pandas, NumPy, Scikit Learn, Matplotlib, NLTK</a:t>
+              <a:t>https://www.kaggle.com/datasets/shuyangli94/food-com-recipes-and-user-interactions</a:t>
             </a:r>
           </a:p>
           <a:p>
@@ -3379,7 +3379,7 @@
                 </a:solidFill>
                 <a:latin typeface="Arial"/>
               </a:rPr>
-              <a:t>Project Repository: </a:t>
+              <a:t>Libraries and Frameworks: </a:t>
             </a:r>
             <a:r>
               <a:rPr sz="1150">
@@ -3388,7 +3388,7 @@
                 </a:solidFill>
                 <a:latin typeface="Arial"/>
               </a:rPr>
-              <a:t>Food.com Recipe Recommendation System by Vidhya Walke</a:t>
+              <a:t>Python, Scikit Surprise, Pandas, NumPy, Scikit Learn, Matplotlib, NLTK</a:t>
             </a:r>
           </a:p>
         </p:txBody>

</xml_diff>